<commit_message>
theme-based segmentation starting with a finance theme
</commit_message>
<xml_diff>
--- a/src/tests/test_intro_slide.pptx
+++ b/src/tests/test_intro_slide.pptx
@@ -3105,7 +3105,7 @@
           <a:noFill/>
         </p:spPr>
         <p:txBody>
-          <a:bodyPr wrap="none">
+          <a:bodyPr wrap="square">
             <a:spAutoFit/>
           </a:bodyPr>
           <a:lstStyle/>
@@ -3143,7 +3143,7 @@
           </a:solidFill>
         </p:spPr>
         <p:txBody>
-          <a:bodyPr wrap="none">
+          <a:bodyPr wrap="square">
             <a:spAutoFit/>
           </a:bodyPr>
           <a:lstStyle/>
@@ -3179,7 +3179,7 @@
           <a:noFill/>
         </p:spPr>
         <p:txBody>
-          <a:bodyPr wrap="none">
+          <a:bodyPr wrap="square">
             <a:spAutoFit/>
           </a:bodyPr>
           <a:lstStyle/>

</xml_diff>